<commit_message>
Align slides, next steps and AI-use statement with Deliverable 1: XY-periodic excluded, median under review, Logical State Space step, class-balance rule and 70/30 recorded honestly
Co-Authored-By: Claude Opus 5.5 <noreply@anthropic.com>
Claude-Session: https://claude.ai/code/session_01SUPoNY4X9N22oC2Pcc4r5C
</commit_message>
<xml_diff>
--- a/presentation/DALAS_TME4_presentation.pptx
+++ b/presentation/DALAS_TME4_presentation.pptx
@@ -3834,7 +3834,7 @@
                 <a:ea typeface="Cambria" pitchFamily="34" charset="-122"/>
                 <a:cs typeface="Cambria" pitchFamily="34" charset="-120"/>
               </a:rPr>
-              <a:t>Complete the data</a:t>
+              <a:t>Summarise the inputs</a:t>
             </a:r>
             <a:endParaRPr lang="en-US" sz="1700" dirty="0"/>
           </a:p>
@@ -3870,7 +3870,7 @@
                   <a:schemeClr val="tx1"/>
                 </a:solidFill>
               </a:rPr>
-              <a:t>Re-harvest the 10 XY-periodic problems with the fixed solver; align the molecules' origin tier across files.</a:t>
+              <a:t>Plot each problem's per-input distributions, then decide how to summarise them; align the molecules' origin tier across files.</a:t>
             </a:r>
             <a:endParaRPr lang="en-US" sz="1400" dirty="0"/>
           </a:p>
@@ -3997,7 +3997,7 @@
                 <a:ea typeface="Cambria" pitchFamily="34" charset="-122"/>
                 <a:cs typeface="Cambria" pitchFamily="34" charset="-120"/>
               </a:rPr>
-              <a:t>Richer structure</a:t>
+              <a:t>Logical State Space</a:t>
             </a:r>
             <a:endParaRPr lang="en-US" sz="1700" dirty="0"/>
           </a:p>
@@ -4033,7 +4033,7 @@
                   <a:schemeClr val="tx1"/>
                 </a:solidFill>
               </a:rPr>
-              <a:t>Hodge features on the factor graph keep how terms overlap: the first test of the 'too coarse' reading of Q3b.</a:t>
+              <a:t>A first instance L = (C; F; Φ), Hodge Laplacians on each factor graph's complex: one medium to explain structure ⇒ function.</a:t>
             </a:r>
             <a:endParaRPr lang="en-US" sz="1400" dirty="0"/>
           </a:p>
@@ -9201,7 +9201,7 @@
                   <a:schemeClr val="tx2"/>
                 </a:solidFill>
               </a:rPr>
-              <a:t>The raw files' sha256 is identical before and after the build. Known gap: XY-periodic (10 problems) lost to a solver failure; fixed, re-harvest pending.</a:t>
+              <a:t>The raw files' sha256 is identical before and after the build. XY-periodic (10 problems) excluded: rejected by the pipeline after a solver failure.</a:t>
             </a:r>
             <a:endParaRPr lang="en-US" sz="1400" dirty="0"/>
           </a:p>
@@ -9513,7 +9513,7 @@
                   <a:schemeClr val="tx1"/>
                 </a:solidFill>
               </a:rPr>
-              <a:t>Locality: terms per site, term sizes, degree spread, support density. Symmetry: colour-refinement classes. Spectrum: entropy, participation ratio and connectivity of the factor graph's Laplacian. Median over each problem's inputs.</a:t>
+              <a:t>Locality: terms per site, term sizes, degree spread, support density. Symmetry: colour-refinement classes. Spectrum: entropy, participation ratio and connectivity of the factor graph's Laplacian. Median over each problem's inputs (to be revisited).</a:t>
             </a:r>
             <a:endParaRPr lang="en-US" sz="1400" dirty="0"/>
           </a:p>

</xml_diff>